<commit_message>
Read every latency row off the same run
Slide 20's table drew rows 2-4 from the deterministic run and rows 1 and 5
from the live one, so it could not add up: semantic resolution, SQL
compilation and database execution summed to 3.98 ms against a combined
total of 3.62 ms, and the same three figures disagreed with Chapter 5 and
the manuscript, which use the live run throughout.

All five rows now come from the live run. The stage medians sum to 3.56 ms
against a 3.62 ms total, which is the ordinary gap between the median of a
sum and the sum of medians rather than two different experiments.

Co-Authored-By: Claude Opus 5 <noreply@anthropic.com>
Claude-Session: https://claude.ai/code/session_01AudYTRar4rAmiaM2SEkcpV
</commit_message>
<xml_diff>
--- a/docs/scripts/Md_Riaz_Final_Defense_0322310105101024.pptx
+++ b/docs/scripts/Md_Riaz_Final_Defense_0322310105101024.pptx
@@ -15905,7 +15905,7 @@
                         </a:defRPr>
                       </a:pPr>
                       <a:r>
-                        <a:t>0.96 ms</a:t>
+                        <a:t>0.89 ms</a:t>
                       </a:r>
                     </a:p>
                   </a:txBody>
@@ -15932,7 +15932,7 @@
                         </a:defRPr>
                       </a:pPr>
                       <a:r>
-                        <a:t>1.46 ms</a:t>
+                        <a:t>1.25 ms</a:t>
                       </a:r>
                     </a:p>
                   </a:txBody>
@@ -16030,7 +16030,7 @@
                         </a:defRPr>
                       </a:pPr>
                       <a:r>
-                        <a:t>0.22 ms</a:t>
+                        <a:t>0.21 ms</a:t>
                       </a:r>
                     </a:p>
                   </a:txBody>
@@ -16109,7 +16109,7 @@
                         </a:defRPr>
                       </a:pPr>
                       <a:r>
-                        <a:t>2.89 ms</a:t>
+                        <a:t>2.54 ms</a:t>
                       </a:r>
                     </a:p>
                   </a:txBody>
@@ -16136,7 +16136,7 @@
                         </a:defRPr>
                       </a:pPr>
                       <a:r>
-                        <a:t>20.41 ms</a:t>
+                        <a:t>12.87 ms</a:t>
                       </a:r>
                     </a:p>
                   </a:txBody>

</xml_diff>

<commit_message>
Read every latency row off the same run (#22)
Slide 20's table drew rows 2-4 from the deterministic run and rows 1 and 5
from the live one, so it could not add up: semantic resolution, SQL
compilation and database execution summed to 3.98 ms against a combined
total of 3.62 ms, and the same three figures disagreed with Chapter 5 and
the manuscript, which use the live run throughout.

All five rows now come from the live run. The stage medians sum to 3.56 ms
against a 3.62 ms total, which is the ordinary gap between the median of a
sum and the sum of medians rather than two different experiments.


Claude-Session: https://claude.ai/code/session_01AudYTRar4rAmiaM2SEkcpV

Co-authored-by: Claude <noreply@anthropic.com>
</commit_message>
<xml_diff>
--- a/docs/scripts/Md_Riaz_Final_Defense_0322310105101024.pptx
+++ b/docs/scripts/Md_Riaz_Final_Defense_0322310105101024.pptx
@@ -15905,7 +15905,7 @@
                         </a:defRPr>
                       </a:pPr>
                       <a:r>
-                        <a:t>0.96 ms</a:t>
+                        <a:t>0.89 ms</a:t>
                       </a:r>
                     </a:p>
                   </a:txBody>
@@ -15932,7 +15932,7 @@
                         </a:defRPr>
                       </a:pPr>
                       <a:r>
-                        <a:t>1.46 ms</a:t>
+                        <a:t>1.25 ms</a:t>
                       </a:r>
                     </a:p>
                   </a:txBody>
@@ -16030,7 +16030,7 @@
                         </a:defRPr>
                       </a:pPr>
                       <a:r>
-                        <a:t>0.22 ms</a:t>
+                        <a:t>0.21 ms</a:t>
                       </a:r>
                     </a:p>
                   </a:txBody>
@@ -16109,7 +16109,7 @@
                         </a:defRPr>
                       </a:pPr>
                       <a:r>
-                        <a:t>2.89 ms</a:t>
+                        <a:t>2.54 ms</a:t>
                       </a:r>
                     </a:p>
                   </a:txBody>
@@ -16136,7 +16136,7 @@
                         </a:defRPr>
                       </a:pPr>
                       <a:r>
-                        <a:t>20.41 ms</a:t>
+                        <a:t>12.87 ms</a:t>
                       </a:r>
                     </a:p>
                   </a:txBody>

</xml_diff>

<commit_message>
Plainen academic jargon in the defense deck
The deck is spoken to a mixed audience, so words that carry no extra
precision over a plain term were replaced on the slides and in the
Bangla speaker notes:
- corpus -> question set
- oracle -> reference (reports)
- differential -> row-by-row comparison
- fidelity -> accuracy, breadth -> coverage
- annotation -> expected answer/intent
- grounding (note) -> partial (fuzzy) word matching

"deterministic" is kept: it is a load-bearing claim (rule-based,
reproducible), not filler, and matches the thesis and paper. Regenerate
the .pptx and .pdf from the updated generator.

Co-Authored-By: Claude Opus 4.8 <noreply@anthropic.com>
Claude-Session: https://claude.ai/code/session_01AudYTRar4rAmiaM2SEkcpV
</commit_message>
<xml_diff>
--- a/docs/scripts/Md_Riaz_Final_Defense_0322310105101024.pptx
+++ b/docs/scripts/Md_Riaz_Final_Defense_0322310105101024.pptx
@@ -1531,7 +1531,7 @@
           </a:p>
           <a:p>
             <a:r>
-              <a:t>মিলতে হবে। grounding fuzzy matching, তাই আচরণে ৯৯.৫%।" </a:t>
+              <a:t>মিলতে হবে। শব্দ মেলানোটা আংশিক-মিল (fuzzy), তাই আচরণে ৯৯.৫%।" </a:t>
             </a:r>
           </a:p>
         </p:txBody>
@@ -2326,7 +2326,7 @@
           </a:p>
           <a:p>
             <a:r>
-              <a:t>রিপোর্টের বিপরীতে differential দিয়ে মেপে দেখানো।"</a:t>
+              <a:t>রিপোর্টের বিপরীতে রো-বাই-রো মিলিয়ে মেপে দেখানো।"</a:t>
             </a:r>
           </a:p>
           <a:p>
@@ -2426,7 +2426,7 @@
           </a:p>
           <a:p>
             <a:r>
-              <a:t>বাকিগুলো এক নিঃশ্বাসে: আরও oracle রিপোর্ট, PostgreSQL ও SQL Server,</a:t>
+              <a:t>বাকিগুলো এক নিঃশ্বাসে: আরও reference রিপোর্ট, PostgreSQL ও SQL Server,</a:t>
             </a:r>
           </a:p>
           <a:p>
@@ -3441,7 +3441,7 @@
           </a:p>
           <a:p>
             <a:r>
-              <a:t>স্বাধীন oracle-এ মাপা — এটায় জোর দিন, কারণ পরের অংশে এটাই ফিরে আসবে।</a:t>
+              <a:t>স্বাধীন reference রিপোর্টে মাপা — এটায় জোর দিন, কারণ পরের অংশে এটাই ফিরে আসবে।</a:t>
             </a:r>
           </a:p>
         </p:txBody>
@@ -3526,7 +3526,7 @@
           </a:p>
           <a:p>
             <a:r>
-              <a:t>একটা উদাহরণ দিন: "যেমন differential টেস্টে ধরা পড়েছিল order-লেভেলের যোগফল</a:t>
+              <a:t>একটা উদাহরণ দিন: "যেমন রো-বাই-রো মিলিয়ে দেখায় ধরা পড়েছিল order-লেভেলের যোগফল</a:t>
             </a:r>
           </a:p>
           <a:p>
@@ -16873,7 +16873,7 @@
                 </a:solidFill>
                 <a:latin typeface="Times New Roman"/>
               </a:rPr>
-              <a:t>425 questions the semantic layer should answer, 75 realistic e-commerce questions it should decline. The same corpus is executed two ways, and they answer different questions.</a:t>
+              <a:t>425 questions the semantic layer should answer, 75 realistic e-commerce questions it should decline. The same question set is run two ways, and they answer different questions.</a:t>
             </a:r>
           </a:p>
         </p:txBody>
@@ -17259,7 +17259,7 @@
                         </a:defRPr>
                       </a:pPr>
                       <a:r>
-                        <a:t>Intent matched the annotation</a:t>
+                        <a:t>Intent matched the expected answer</a:t>
                       </a:r>
                     </a:p>
                   </a:txBody>
@@ -17448,7 +17448,7 @@
                 </a:solidFill>
                 <a:latin typeface="Times New Roman"/>
               </a:rPr>
-              <a:t> committed intent annotations are fed straight to the mapper, so it tests the compiler, not the pipeline. Only the right column is an end-to-end result, and it is the one to quote.</a:t>
+              <a:t> saved expected intents are fed straight to the mapper, so it tests the compiler, not the pipeline. Only the right column is an end-to-end result, and it is the one to quote.</a:t>
             </a:r>
           </a:p>
           <a:p>
@@ -18596,7 +18596,7 @@
                 </a:solidFill>
                 <a:latin typeface="Times New Roman"/>
               </a:rPr>
-              <a:t>Median and 95th-percentile time per question, measured on the supported questions of the 500-question corpus.</a:t>
+              <a:t>Median and 95th-percentile time per question, measured on the supported questions in the 500-question set.</a:t>
             </a:r>
           </a:p>
         </p:txBody>
@@ -23860,7 +23860,7 @@
                 </a:solidFill>
                 <a:latin typeface="Times New Roman"/>
               </a:rPr>
-              <a:t>- The nopCommerce [7] prototype, the 500-question corpus, and the differential against the platform's own report logic show that the approach can be implemented and evaluated practically.</a:t>
+              <a:t>- The nopCommerce [7] prototype, the 500-question set, and the row-by-row comparison against the platform's own reports show that the approach can be implemented and evaluated practically.</a:t>
             </a:r>
           </a:p>
           <a:p>
@@ -24356,7 +24356,7 @@
                 </a:solidFill>
                 <a:latin typeface="Times New Roman"/>
               </a:rPr>
-              <a:t>- Add more oracle reports from real admin and business workflows.</a:t>
+              <a:t>- Add more reference reports from real admin and business workflows.</a:t>
             </a:r>
           </a:p>
           <a:p>
@@ -32159,7 +32159,7 @@
                         </a:defRPr>
                       </a:pPr>
                       <a:r>
-                        <a:t>Evaluate against an independent oracle</a:t>
+                        <a:t>Evaluate against an independent reference</a:t>
                       </a:r>
                     </a:p>
                   </a:txBody>
@@ -32186,7 +32186,7 @@
                         </a:defRPr>
                       </a:pPr>
                       <a:r>
-                        <a:t>Measure breadth on 500 fixed natural-language questions, and fidelity against nopCommerce's own twenty admin reports.</a:t>
+                        <a:t>Measure coverage on 500 fixed natural-language questions, and accuracy against nopCommerce's own twenty admin reports.</a:t>
                       </a:r>
                     </a:p>
                   </a:txBody>

</xml_diff>

<commit_message>
Plainen academic jargon in the defense deck (#26)
The deck is spoken to a mixed audience, so words that carry no extra
precision over a plain term were replaced on the slides and in the
Bangla speaker notes:
- corpus -> question set
- oracle -> reference (reports)
- differential -> row-by-row comparison
- fidelity -> accuracy, breadth -> coverage
- annotation -> expected answer/intent
- grounding (note) -> partial (fuzzy) word matching

"deterministic" is kept: it is a load-bearing claim (rule-based,
reproducible), not filler, and matches the thesis and paper. Regenerate
the .pptx and .pdf from the updated generator.


Claude-Session: https://claude.ai/code/session_01AudYTRar4rAmiaM2SEkcpV

Co-authored-by: Claude <noreply@anthropic.com>
</commit_message>
<xml_diff>
--- a/docs/scripts/Md_Riaz_Final_Defense_0322310105101024.pptx
+++ b/docs/scripts/Md_Riaz_Final_Defense_0322310105101024.pptx
@@ -1531,7 +1531,7 @@
           </a:p>
           <a:p>
             <a:r>
-              <a:t>মিলতে হবে। grounding fuzzy matching, তাই আচরণে ৯৯.৫%।" </a:t>
+              <a:t>মিলতে হবে। শব্দ মেলানোটা আংশিক-মিল (fuzzy), তাই আচরণে ৯৯.৫%।" </a:t>
             </a:r>
           </a:p>
         </p:txBody>
@@ -2326,7 +2326,7 @@
           </a:p>
           <a:p>
             <a:r>
-              <a:t>রিপোর্টের বিপরীতে differential দিয়ে মেপে দেখানো।"</a:t>
+              <a:t>রিপোর্টের বিপরীতে রো-বাই-রো মিলিয়ে মেপে দেখানো।"</a:t>
             </a:r>
           </a:p>
           <a:p>
@@ -2426,7 +2426,7 @@
           </a:p>
           <a:p>
             <a:r>
-              <a:t>বাকিগুলো এক নিঃশ্বাসে: আরও oracle রিপোর্ট, PostgreSQL ও SQL Server,</a:t>
+              <a:t>বাকিগুলো এক নিঃশ্বাসে: আরও reference রিপোর্ট, PostgreSQL ও SQL Server,</a:t>
             </a:r>
           </a:p>
           <a:p>
@@ -3441,7 +3441,7 @@
           </a:p>
           <a:p>
             <a:r>
-              <a:t>স্বাধীন oracle-এ মাপা — এটায় জোর দিন, কারণ পরের অংশে এটাই ফিরে আসবে।</a:t>
+              <a:t>স্বাধীন reference রিপোর্টে মাপা — এটায় জোর দিন, কারণ পরের অংশে এটাই ফিরে আসবে।</a:t>
             </a:r>
           </a:p>
         </p:txBody>
@@ -3526,7 +3526,7 @@
           </a:p>
           <a:p>
             <a:r>
-              <a:t>একটা উদাহরণ দিন: "যেমন differential টেস্টে ধরা পড়েছিল order-লেভেলের যোগফল</a:t>
+              <a:t>একটা উদাহরণ দিন: "যেমন রো-বাই-রো মিলিয়ে দেখায় ধরা পড়েছিল order-লেভেলের যোগফল</a:t>
             </a:r>
           </a:p>
           <a:p>
@@ -16873,7 +16873,7 @@
                 </a:solidFill>
                 <a:latin typeface="Times New Roman"/>
               </a:rPr>
-              <a:t>425 questions the semantic layer should answer, 75 realistic e-commerce questions it should decline. The same corpus is executed two ways, and they answer different questions.</a:t>
+              <a:t>425 questions the semantic layer should answer, 75 realistic e-commerce questions it should decline. The same question set is run two ways, and they answer different questions.</a:t>
             </a:r>
           </a:p>
         </p:txBody>
@@ -17259,7 +17259,7 @@
                         </a:defRPr>
                       </a:pPr>
                       <a:r>
-                        <a:t>Intent matched the annotation</a:t>
+                        <a:t>Intent matched the expected answer</a:t>
                       </a:r>
                     </a:p>
                   </a:txBody>
@@ -17448,7 +17448,7 @@
                 </a:solidFill>
                 <a:latin typeface="Times New Roman"/>
               </a:rPr>
-              <a:t> committed intent annotations are fed straight to the mapper, so it tests the compiler, not the pipeline. Only the right column is an end-to-end result, and it is the one to quote.</a:t>
+              <a:t> saved expected intents are fed straight to the mapper, so it tests the compiler, not the pipeline. Only the right column is an end-to-end result, and it is the one to quote.</a:t>
             </a:r>
           </a:p>
           <a:p>
@@ -18596,7 +18596,7 @@
                 </a:solidFill>
                 <a:latin typeface="Times New Roman"/>
               </a:rPr>
-              <a:t>Median and 95th-percentile time per question, measured on the supported questions of the 500-question corpus.</a:t>
+              <a:t>Median and 95th-percentile time per question, measured on the supported questions in the 500-question set.</a:t>
             </a:r>
           </a:p>
         </p:txBody>
@@ -23860,7 +23860,7 @@
                 </a:solidFill>
                 <a:latin typeface="Times New Roman"/>
               </a:rPr>
-              <a:t>- The nopCommerce [7] prototype, the 500-question corpus, and the differential against the platform's own report logic show that the approach can be implemented and evaluated practically.</a:t>
+              <a:t>- The nopCommerce [7] prototype, the 500-question set, and the row-by-row comparison against the platform's own reports show that the approach can be implemented and evaluated practically.</a:t>
             </a:r>
           </a:p>
           <a:p>
@@ -24356,7 +24356,7 @@
                 </a:solidFill>
                 <a:latin typeface="Times New Roman"/>
               </a:rPr>
-              <a:t>- Add more oracle reports from real admin and business workflows.</a:t>
+              <a:t>- Add more reference reports from real admin and business workflows.</a:t>
             </a:r>
           </a:p>
           <a:p>
@@ -32159,7 +32159,7 @@
                         </a:defRPr>
                       </a:pPr>
                       <a:r>
-                        <a:t>Evaluate against an independent oracle</a:t>
+                        <a:t>Evaluate against an independent reference</a:t>
                       </a:r>
                     </a:p>
                   </a:txBody>
@@ -32186,7 +32186,7 @@
                         </a:defRPr>
                       </a:pPr>
                       <a:r>
-                        <a:t>Measure breadth on 500 fixed natural-language questions, and fidelity against nopCommerce's own twenty admin reports.</a:t>
+                        <a:t>Measure coverage on 500 fixed natural-language questions, and accuracy against nopCommerce's own twenty admin reports.</a:t>
                       </a:r>
                     </a:p>
                   </a:txBody>

</xml_diff>

<commit_message>
Set the defense date in the deck footer
Replace the placeholder footer date with the scheduled final-defense
date, Saturday, November 7, 2026. Regenerate the .pptx and .pdf.

Co-Authored-By: Claude Opus 4.8 <noreply@anthropic.com>
Claude-Session: https://claude.ai/code/session_01AudYTRar4rAmiaM2SEkcpV
</commit_message>
<xml_diff>
--- a/docs/scripts/Md_Riaz_Final_Defense_0322310105101024.pptx
+++ b/docs/scripts/Md_Riaz_Final_Defense_0322310105101024.pptx
@@ -7634,7 +7634,7 @@
               </a:defRPr>
             </a:pPr>
             <a:r>
-              <a:t>Tuesday, August 18, 2026</a:t>
+              <a:t>Saturday, November 7, 2026</a:t>
             </a:r>
           </a:p>
         </p:txBody>
@@ -8021,7 +8021,7 @@
               </a:defRPr>
             </a:pPr>
             <a:r>
-              <a:t>Tuesday, August 18, 2026</a:t>
+              <a:t>Saturday, November 7, 2026</a:t>
             </a:r>
           </a:p>
         </p:txBody>
@@ -8608,7 +8608,7 @@
               </a:defRPr>
             </a:pPr>
             <a:r>
-              <a:t>Tuesday, August 18, 2026</a:t>
+              <a:t>Saturday, November 7, 2026</a:t>
             </a:r>
           </a:p>
         </p:txBody>
@@ -9921,7 +9921,7 @@
               </a:defRPr>
             </a:pPr>
             <a:r>
-              <a:t>Tuesday, August 18, 2026</a:t>
+              <a:t>Saturday, November 7, 2026</a:t>
             </a:r>
           </a:p>
         </p:txBody>
@@ -11119,7 +11119,7 @@
               </a:defRPr>
             </a:pPr>
             <a:r>
-              <a:t>Tuesday, August 18, 2026</a:t>
+              <a:t>Saturday, November 7, 2026</a:t>
             </a:r>
           </a:p>
         </p:txBody>
@@ -12435,7 +12435,7 @@
               </a:defRPr>
             </a:pPr>
             <a:r>
-              <a:t>Tuesday, August 18, 2026</a:t>
+              <a:t>Saturday, November 7, 2026</a:t>
             </a:r>
           </a:p>
         </p:txBody>
@@ -13678,7 +13678,7 @@
               </a:defRPr>
             </a:pPr>
             <a:r>
-              <a:t>Tuesday, August 18, 2026</a:t>
+              <a:t>Saturday, November 7, 2026</a:t>
             </a:r>
           </a:p>
         </p:txBody>
@@ -15031,7 +15031,7 @@
               </a:defRPr>
             </a:pPr>
             <a:r>
-              <a:t>Tuesday, August 18, 2026</a:t>
+              <a:t>Saturday, November 7, 2026</a:t>
             </a:r>
           </a:p>
         </p:txBody>
@@ -15609,7 +15609,7 @@
               </a:defRPr>
             </a:pPr>
             <a:r>
-              <a:t>Tuesday, August 18, 2026</a:t>
+              <a:t>Saturday, November 7, 2026</a:t>
             </a:r>
           </a:p>
         </p:txBody>
@@ -16764,7 +16764,7 @@
               </a:defRPr>
             </a:pPr>
             <a:r>
-              <a:t>Tuesday, August 18, 2026</a:t>
+              <a:t>Saturday, November 7, 2026</a:t>
             </a:r>
           </a:p>
         </p:txBody>
@@ -17841,7 +17841,7 @@
               </a:defRPr>
             </a:pPr>
             <a:r>
-              <a:t>Tuesday, August 18, 2026</a:t>
+              <a:t>Saturday, November 7, 2026</a:t>
             </a:r>
           </a:p>
         </p:txBody>
@@ -18487,7 +18487,7 @@
               </a:defRPr>
             </a:pPr>
             <a:r>
-              <a:t>Tuesday, August 18, 2026</a:t>
+              <a:t>Saturday, November 7, 2026</a:t>
             </a:r>
           </a:p>
         </p:txBody>
@@ -19602,7 +19602,7 @@
               </a:defRPr>
             </a:pPr>
             <a:r>
-              <a:t>Tuesday, August 18, 2026</a:t>
+              <a:t>Saturday, November 7, 2026</a:t>
             </a:r>
           </a:p>
         </p:txBody>
@@ -20698,7 +20698,7 @@
               </a:defRPr>
             </a:pPr>
             <a:r>
-              <a:t>Tuesday, August 18, 2026</a:t>
+              <a:t>Saturday, November 7, 2026</a:t>
             </a:r>
           </a:p>
         </p:txBody>
@@ -21787,7 +21787,7 @@
               </a:defRPr>
             </a:pPr>
             <a:r>
-              <a:t>Tuesday, August 18, 2026</a:t>
+              <a:t>Saturday, November 7, 2026</a:t>
             </a:r>
           </a:p>
         </p:txBody>
@@ -22622,7 +22622,7 @@
               </a:defRPr>
             </a:pPr>
             <a:r>
-              <a:t>Tuesday, August 18, 2026</a:t>
+              <a:t>Saturday, November 7, 2026</a:t>
             </a:r>
           </a:p>
         </p:txBody>
@@ -23149,7 +23149,7 @@
               </a:defRPr>
             </a:pPr>
             <a:r>
-              <a:t>Tuesday, August 18, 2026</a:t>
+              <a:t>Saturday, November 7, 2026</a:t>
             </a:r>
           </a:p>
         </p:txBody>
@@ -23663,7 +23663,7 @@
               </a:defRPr>
             </a:pPr>
             <a:r>
-              <a:t>Tuesday, August 18, 2026</a:t>
+              <a:t>Saturday, November 7, 2026</a:t>
             </a:r>
           </a:p>
         </p:txBody>
@@ -24203,7 +24203,7 @@
               </a:defRPr>
             </a:pPr>
             <a:r>
-              <a:t>Tuesday, August 18, 2026</a:t>
+              <a:t>Saturday, November 7, 2026</a:t>
             </a:r>
           </a:p>
         </p:txBody>
@@ -24721,7 +24721,7 @@
               </a:defRPr>
             </a:pPr>
             <a:r>
-              <a:t>Tuesday, August 18, 2026</a:t>
+              <a:t>Saturday, November 7, 2026</a:t>
             </a:r>
           </a:p>
         </p:txBody>
@@ -25240,7 +25240,7 @@
               </a:defRPr>
             </a:pPr>
             <a:r>
-              <a:t>Tuesday, August 18, 2026</a:t>
+              <a:t>Saturday, November 7, 2026</a:t>
             </a:r>
           </a:p>
         </p:txBody>
@@ -25654,7 +25654,7 @@
               </a:defRPr>
             </a:pPr>
             <a:r>
-              <a:t>Tuesday, August 18, 2026</a:t>
+              <a:t>Saturday, November 7, 2026</a:t>
             </a:r>
           </a:p>
         </p:txBody>
@@ -26260,7 +26260,7 @@
               </a:defRPr>
             </a:pPr>
             <a:r>
-              <a:t>Tuesday, August 18, 2026</a:t>
+              <a:t>Saturday, November 7, 2026</a:t>
             </a:r>
           </a:p>
         </p:txBody>
@@ -27234,7 +27234,7 @@
               </a:defRPr>
             </a:pPr>
             <a:r>
-              <a:t>Tuesday, August 18, 2026</a:t>
+              <a:t>Saturday, November 7, 2026</a:t>
             </a:r>
           </a:p>
         </p:txBody>
@@ -27951,7 +27951,7 @@
               </a:defRPr>
             </a:pPr>
             <a:r>
-              <a:t>Tuesday, August 18, 2026</a:t>
+              <a:t>Saturday, November 7, 2026</a:t>
             </a:r>
           </a:p>
         </p:txBody>
@@ -28722,7 +28722,7 @@
               </a:defRPr>
             </a:pPr>
             <a:r>
-              <a:t>Tuesday, August 18, 2026</a:t>
+              <a:t>Saturday, November 7, 2026</a:t>
             </a:r>
           </a:p>
         </p:txBody>
@@ -29262,7 +29262,7 @@
               </a:defRPr>
             </a:pPr>
             <a:r>
-              <a:t>Tuesday, August 18, 2026</a:t>
+              <a:t>Saturday, November 7, 2026</a:t>
             </a:r>
           </a:p>
         </p:txBody>
@@ -30321,7 +30321,7 @@
               </a:defRPr>
             </a:pPr>
             <a:r>
-              <a:t>Tuesday, August 18, 2026</a:t>
+              <a:t>Saturday, November 7, 2026</a:t>
             </a:r>
           </a:p>
         </p:txBody>
@@ -31324,7 +31324,7 @@
               </a:defRPr>
             </a:pPr>
             <a:r>
-              <a:t>Tuesday, August 18, 2026</a:t>
+              <a:t>Saturday, November 7, 2026</a:t>
             </a:r>
           </a:p>
         </p:txBody>
@@ -31842,7 +31842,7 @@
               </a:defRPr>
             </a:pPr>
             <a:r>
-              <a:t>Tuesday, August 18, 2026</a:t>
+              <a:t>Saturday, November 7, 2026</a:t>
             </a:r>
           </a:p>
         </p:txBody>
@@ -32495,7 +32495,7 @@
               </a:defRPr>
             </a:pPr>
             <a:r>
-              <a:t>Tuesday, August 18, 2026</a:t>
+              <a:t>Saturday, November 7, 2026</a:t>
             </a:r>
           </a:p>
         </p:txBody>

</xml_diff>

<commit_message>
Set the defense date in the deck footer (#27)
Replace the placeholder footer date with the scheduled final-defense
date, Saturday, November 7, 2026. Regenerate the .pptx and .pdf.


Claude-Session: https://claude.ai/code/session_01AudYTRar4rAmiaM2SEkcpV

Co-authored-by: Claude <noreply@anthropic.com>
</commit_message>
<xml_diff>
--- a/docs/scripts/Md_Riaz_Final_Defense_0322310105101024.pptx
+++ b/docs/scripts/Md_Riaz_Final_Defense_0322310105101024.pptx
@@ -7634,7 +7634,7 @@
               </a:defRPr>
             </a:pPr>
             <a:r>
-              <a:t>Tuesday, August 18, 2026</a:t>
+              <a:t>Saturday, November 7, 2026</a:t>
             </a:r>
           </a:p>
         </p:txBody>
@@ -8021,7 +8021,7 @@
               </a:defRPr>
             </a:pPr>
             <a:r>
-              <a:t>Tuesday, August 18, 2026</a:t>
+              <a:t>Saturday, November 7, 2026</a:t>
             </a:r>
           </a:p>
         </p:txBody>
@@ -8608,7 +8608,7 @@
               </a:defRPr>
             </a:pPr>
             <a:r>
-              <a:t>Tuesday, August 18, 2026</a:t>
+              <a:t>Saturday, November 7, 2026</a:t>
             </a:r>
           </a:p>
         </p:txBody>
@@ -9921,7 +9921,7 @@
               </a:defRPr>
             </a:pPr>
             <a:r>
-              <a:t>Tuesday, August 18, 2026</a:t>
+              <a:t>Saturday, November 7, 2026</a:t>
             </a:r>
           </a:p>
         </p:txBody>
@@ -11119,7 +11119,7 @@
               </a:defRPr>
             </a:pPr>
             <a:r>
-              <a:t>Tuesday, August 18, 2026</a:t>
+              <a:t>Saturday, November 7, 2026</a:t>
             </a:r>
           </a:p>
         </p:txBody>
@@ -12435,7 +12435,7 @@
               </a:defRPr>
             </a:pPr>
             <a:r>
-              <a:t>Tuesday, August 18, 2026</a:t>
+              <a:t>Saturday, November 7, 2026</a:t>
             </a:r>
           </a:p>
         </p:txBody>
@@ -13678,7 +13678,7 @@
               </a:defRPr>
             </a:pPr>
             <a:r>
-              <a:t>Tuesday, August 18, 2026</a:t>
+              <a:t>Saturday, November 7, 2026</a:t>
             </a:r>
           </a:p>
         </p:txBody>
@@ -15031,7 +15031,7 @@
               </a:defRPr>
             </a:pPr>
             <a:r>
-              <a:t>Tuesday, August 18, 2026</a:t>
+              <a:t>Saturday, November 7, 2026</a:t>
             </a:r>
           </a:p>
         </p:txBody>
@@ -15609,7 +15609,7 @@
               </a:defRPr>
             </a:pPr>
             <a:r>
-              <a:t>Tuesday, August 18, 2026</a:t>
+              <a:t>Saturday, November 7, 2026</a:t>
             </a:r>
           </a:p>
         </p:txBody>
@@ -16764,7 +16764,7 @@
               </a:defRPr>
             </a:pPr>
             <a:r>
-              <a:t>Tuesday, August 18, 2026</a:t>
+              <a:t>Saturday, November 7, 2026</a:t>
             </a:r>
           </a:p>
         </p:txBody>
@@ -17841,7 +17841,7 @@
               </a:defRPr>
             </a:pPr>
             <a:r>
-              <a:t>Tuesday, August 18, 2026</a:t>
+              <a:t>Saturday, November 7, 2026</a:t>
             </a:r>
           </a:p>
         </p:txBody>
@@ -18487,7 +18487,7 @@
               </a:defRPr>
             </a:pPr>
             <a:r>
-              <a:t>Tuesday, August 18, 2026</a:t>
+              <a:t>Saturday, November 7, 2026</a:t>
             </a:r>
           </a:p>
         </p:txBody>
@@ -19602,7 +19602,7 @@
               </a:defRPr>
             </a:pPr>
             <a:r>
-              <a:t>Tuesday, August 18, 2026</a:t>
+              <a:t>Saturday, November 7, 2026</a:t>
             </a:r>
           </a:p>
         </p:txBody>
@@ -20698,7 +20698,7 @@
               </a:defRPr>
             </a:pPr>
             <a:r>
-              <a:t>Tuesday, August 18, 2026</a:t>
+              <a:t>Saturday, November 7, 2026</a:t>
             </a:r>
           </a:p>
         </p:txBody>
@@ -21787,7 +21787,7 @@
               </a:defRPr>
             </a:pPr>
             <a:r>
-              <a:t>Tuesday, August 18, 2026</a:t>
+              <a:t>Saturday, November 7, 2026</a:t>
             </a:r>
           </a:p>
         </p:txBody>
@@ -22622,7 +22622,7 @@
               </a:defRPr>
             </a:pPr>
             <a:r>
-              <a:t>Tuesday, August 18, 2026</a:t>
+              <a:t>Saturday, November 7, 2026</a:t>
             </a:r>
           </a:p>
         </p:txBody>
@@ -23149,7 +23149,7 @@
               </a:defRPr>
             </a:pPr>
             <a:r>
-              <a:t>Tuesday, August 18, 2026</a:t>
+              <a:t>Saturday, November 7, 2026</a:t>
             </a:r>
           </a:p>
         </p:txBody>
@@ -23663,7 +23663,7 @@
               </a:defRPr>
             </a:pPr>
             <a:r>
-              <a:t>Tuesday, August 18, 2026</a:t>
+              <a:t>Saturday, November 7, 2026</a:t>
             </a:r>
           </a:p>
         </p:txBody>
@@ -24203,7 +24203,7 @@
               </a:defRPr>
             </a:pPr>
             <a:r>
-              <a:t>Tuesday, August 18, 2026</a:t>
+              <a:t>Saturday, November 7, 2026</a:t>
             </a:r>
           </a:p>
         </p:txBody>
@@ -24721,7 +24721,7 @@
               </a:defRPr>
             </a:pPr>
             <a:r>
-              <a:t>Tuesday, August 18, 2026</a:t>
+              <a:t>Saturday, November 7, 2026</a:t>
             </a:r>
           </a:p>
         </p:txBody>
@@ -25240,7 +25240,7 @@
               </a:defRPr>
             </a:pPr>
             <a:r>
-              <a:t>Tuesday, August 18, 2026</a:t>
+              <a:t>Saturday, November 7, 2026</a:t>
             </a:r>
           </a:p>
         </p:txBody>
@@ -25654,7 +25654,7 @@
               </a:defRPr>
             </a:pPr>
             <a:r>
-              <a:t>Tuesday, August 18, 2026</a:t>
+              <a:t>Saturday, November 7, 2026</a:t>
             </a:r>
           </a:p>
         </p:txBody>
@@ -26260,7 +26260,7 @@
               </a:defRPr>
             </a:pPr>
             <a:r>
-              <a:t>Tuesday, August 18, 2026</a:t>
+              <a:t>Saturday, November 7, 2026</a:t>
             </a:r>
           </a:p>
         </p:txBody>
@@ -27234,7 +27234,7 @@
               </a:defRPr>
             </a:pPr>
             <a:r>
-              <a:t>Tuesday, August 18, 2026</a:t>
+              <a:t>Saturday, November 7, 2026</a:t>
             </a:r>
           </a:p>
         </p:txBody>
@@ -27951,7 +27951,7 @@
               </a:defRPr>
             </a:pPr>
             <a:r>
-              <a:t>Tuesday, August 18, 2026</a:t>
+              <a:t>Saturday, November 7, 2026</a:t>
             </a:r>
           </a:p>
         </p:txBody>
@@ -28722,7 +28722,7 @@
               </a:defRPr>
             </a:pPr>
             <a:r>
-              <a:t>Tuesday, August 18, 2026</a:t>
+              <a:t>Saturday, November 7, 2026</a:t>
             </a:r>
           </a:p>
         </p:txBody>
@@ -29262,7 +29262,7 @@
               </a:defRPr>
             </a:pPr>
             <a:r>
-              <a:t>Tuesday, August 18, 2026</a:t>
+              <a:t>Saturday, November 7, 2026</a:t>
             </a:r>
           </a:p>
         </p:txBody>
@@ -30321,7 +30321,7 @@
               </a:defRPr>
             </a:pPr>
             <a:r>
-              <a:t>Tuesday, August 18, 2026</a:t>
+              <a:t>Saturday, November 7, 2026</a:t>
             </a:r>
           </a:p>
         </p:txBody>
@@ -31324,7 +31324,7 @@
               </a:defRPr>
             </a:pPr>
             <a:r>
-              <a:t>Tuesday, August 18, 2026</a:t>
+              <a:t>Saturday, November 7, 2026</a:t>
             </a:r>
           </a:p>
         </p:txBody>
@@ -31842,7 +31842,7 @@
               </a:defRPr>
             </a:pPr>
             <a:r>
-              <a:t>Tuesday, August 18, 2026</a:t>
+              <a:t>Saturday, November 7, 2026</a:t>
             </a:r>
           </a:p>
         </p:txBody>
@@ -32495,7 +32495,7 @@
               </a:defRPr>
             </a:pPr>
             <a:r>
-              <a:t>Tuesday, August 18, 2026</a:t>
+              <a:t>Saturday, November 7, 2026</a:t>
             </a:r>
           </a:p>
         </p:txBody>

</xml_diff>